<commit_message>
docs: ground benchmark metrics with empirical mean +- std, parameter count, and GPU labeling
</commit_message>
<xml_diff>
--- a/solution_presentation.pptx
+++ b/solution_presentation.pptx
@@ -3201,7 +3201,7 @@
               </a:defRPr>
             </a:pPr>
             <a:r>
-              <a:t>KLA Hackathon 2026 — SEMICON India / SEMI-IESA | Solution Submission</a:t>
+              <a:t>KLA Hackathon 2026 — SEMICON India | Solution Submission</a:t>
             </a:r>
           </a:p>
         </p:txBody>
@@ -3258,7 +3258,7 @@
                   <a:srgbClr val="0F172A"/>
                 </a:solidFill>
               </a:rPr>
-              <a:t>•  Team Architecture: </a:t>
+              <a:t>*  Team Architecture: </a:t>
             </a:r>
             <a:r>
               <a:rPr sz="1250">
@@ -3281,7 +3281,7 @@
                   <a:srgbClr val="0F172A"/>
                 </a:solidFill>
               </a:rPr>
-              <a:t>•  Problem Statement: </a:t>
+              <a:t>*  Problem Statement: </a:t>
             </a:r>
             <a:r>
               <a:rPr sz="1250">
@@ -3304,7 +3304,7 @@
                   <a:srgbClr val="0F172A"/>
                 </a:solidFill>
               </a:rPr>
-              <a:t>•  Core Innovation: </a:t>
+              <a:t>*  Core Innovation: </a:t>
             </a:r>
             <a:r>
               <a:rPr sz="1250">
@@ -3327,7 +3327,7 @@
                   <a:srgbClr val="0F172A"/>
                 </a:solidFill>
               </a:rPr>
-              <a:t>•  Key Result: </a:t>
+              <a:t>*  Key Result: </a:t>
             </a:r>
             <a:r>
               <a:rPr sz="1250">
@@ -3335,7 +3335,7 @@
                   <a:srgbClr val="1E293B"/>
                 </a:solidFill>
               </a:rPr>
-              <a:t>Peak Validation PSNR: 28.16 dB (+5.15 dB gain vs. Bicubic baseline, +0.99 dB over classical U-Net)</a:t>
+              <a:t>Peak Validation PSNR: 28.16 ± 5.02 dB (vs 23.01 ± 3.65 dB Bicubic baseline), SSIM: 0.7661 ± 0.1571</a:t>
             </a:r>
           </a:p>
           <a:p>
@@ -3350,7 +3350,7 @@
                   <a:srgbClr val="0F172A"/>
                 </a:solidFill>
               </a:rPr>
-              <a:t>•  Inference Throughput: </a:t>
+              <a:t>*  Hardware Context: </a:t>
             </a:r>
             <a:r>
               <a:rPr sz="1250">
@@ -3358,7 +3358,7 @@
                   <a:srgbClr val="1E293B"/>
                 </a:solidFill>
               </a:rPr>
-              <a:t>&gt;350 FPS on GPU (&lt;2.8 ms/image), strictly adhering to zero-touch evaluator contract</a:t>
+              <a:t>Benchmarked on NVIDIA GeForce RTX 3050 Laptop GPU (4GB VRAM) adhering to zero-touch CLI contract</a:t>
             </a:r>
           </a:p>
         </p:txBody>
@@ -3474,7 +3474,7 @@
             <a:avLst/>
           </a:prstGeom>
           <a:solidFill>
-            <a:srgbClr val="0052CC"/>
+            <a:srgbClr val="403294"/>
           </a:solidFill>
           <a:ln>
             <a:noFill/>
@@ -3518,7 +3518,7 @@
               </a:defRPr>
             </a:pPr>
             <a:r>
-              <a:t>Benchmarked for High-Throughput In-Line Semiconductor Fab Inspection</a:t>
+              <a:t>Benchmarked on NVIDIA GeForce RTX 3050 Laptop GPU (4GB VRAM)</a:t>
             </a:r>
           </a:p>
         </p:txBody>
@@ -3575,7 +3575,7 @@
                   <a:srgbClr val="0F172A"/>
                 </a:solidFill>
               </a:rPr>
-              <a:t>•  End-to-End Latency: </a:t>
+              <a:t>*  Single-Image Latency (Batch=1): </a:t>
             </a:r>
             <a:r>
               <a:rPr sz="1250">
@@ -3583,7 +3583,7 @@
                   <a:srgbClr val="1E293B"/>
                 </a:solidFill>
               </a:rPr>
-              <a:t>2.8 ms per image on NVIDIA GPU (including float32 conversion, tensor forward, and output saving).</a:t>
+              <a:t>39.10 ± 8.41 ms (25.6 FPS) on NVIDIA GeForce RTX 3050 Laptop GPU.</a:t>
             </a:r>
           </a:p>
           <a:p>
@@ -3598,7 +3598,7 @@
                   <a:srgbClr val="0F172A"/>
                 </a:solidFill>
               </a:rPr>
-              <a:t>•  Inference Throughput: </a:t>
+              <a:t>*  Batched Latency (Batch=8): </a:t>
             </a:r>
             <a:r>
               <a:rPr sz="1250">
@@ -3606,7 +3606,7 @@
                   <a:srgbClr val="1E293B"/>
                 </a:solidFill>
               </a:rPr>
-              <a:t>&gt;350 images/second (&gt;350 FPS), exceeding high-speed automated defect inspection (ADI) throughput demands.</a:t>
+              <a:t>10.97 ms per image effective (91.2 FPS throughput).</a:t>
             </a:r>
           </a:p>
           <a:p>
@@ -3621,7 +3621,7 @@
                   <a:srgbClr val="0F172A"/>
                 </a:solidFill>
               </a:rPr>
-              <a:t>•  Hardware Utilization: </a:t>
+              <a:t>*  Hardware Context: </a:t>
             </a:r>
             <a:r>
               <a:rPr sz="1250">
@@ -3629,7 +3629,7 @@
                   <a:srgbClr val="1E293B"/>
                 </a:solidFill>
               </a:rPr>
-              <a:t>NVIDIA TensorFloat-32 (TF32) execution utilizing Tensor Cores at 100% compute efficiency with &lt;1.2 GB VRAM peak.</a:t>
+              <a:t>RTX 3050 (2048 cores, 4GB) is lower-tier compared to RTX 4050 (2560 cores, 6GB) used in baseline repo.</a:t>
             </a:r>
           </a:p>
           <a:p>
@@ -3644,7 +3644,7 @@
                   <a:srgbClr val="0F172A"/>
                 </a:solidFill>
               </a:rPr>
-              <a:t>•  Scalability: </a:t>
+              <a:t>*  Peak Memory Footprint: </a:t>
             </a:r>
             <a:r>
               <a:rPr sz="1250">
@@ -3652,7 +3652,7 @@
                   <a:srgbClr val="1E293B"/>
                 </a:solidFill>
               </a:rPr>
-              <a:t>Lightweight memory footprint enables concurrent multi-die batch inference on modern fab GPUs (NVIDIA RTX / H100).</a:t>
+              <a:t>284.0 MB VRAM peak, easily deployable on memory-constrained inspection workstations.</a:t>
             </a:r>
           </a:p>
         </p:txBody>
@@ -3768,7 +3768,7 @@
             <a:avLst/>
           </a:prstGeom>
           <a:solidFill>
-            <a:srgbClr val="0052CC"/>
+            <a:srgbClr val="505F79"/>
           </a:solidFill>
           <a:ln>
             <a:noFill/>
@@ -3869,7 +3869,7 @@
                   <a:srgbClr val="0F172A"/>
                 </a:solidFill>
               </a:rPr>
-              <a:t>•  Visual Fidelity: </a:t>
+              <a:t>*  Visual Fidelity: </a:t>
             </a:r>
             <a:r>
               <a:rPr sz="1250">
@@ -3892,7 +3892,7 @@
                   <a:srgbClr val="0F172A"/>
                 </a:solidFill>
               </a:rPr>
-              <a:t>•  High-Frequency Pitch Recovery: </a:t>
+              <a:t>*  High-Frequency Pitch Recovery: </a:t>
             </a:r>
             <a:r>
               <a:rPr sz="1250">
@@ -3915,7 +3915,7 @@
                   <a:srgbClr val="0F172A"/>
                 </a:solidFill>
               </a:rPr>
-              <a:t>•  Edge-Case Failure Analysis: </a:t>
+              <a:t>*  Edge-Case Failure Analysis: </a:t>
             </a:r>
             <a:r>
               <a:rPr sz="1250">
@@ -3938,7 +3938,7 @@
                   <a:srgbClr val="0F172A"/>
                 </a:solidFill>
               </a:rPr>
-              <a:t>•  Mitigation Strategy: </a:t>
+              <a:t>*  Mitigation Strategy: </a:t>
             </a:r>
             <a:r>
               <a:rPr sz="1250">
@@ -4163,7 +4163,7 @@
                   <a:srgbClr val="0F172A"/>
                 </a:solidFill>
               </a:rPr>
-              <a:t>•  GitHub Repository: </a:t>
+              <a:t>*  GitHub Repository: </a:t>
             </a:r>
             <a:r>
               <a:rPr sz="1250">
@@ -4171,7 +4171,7 @@
                   <a:srgbClr val="1E293B"/>
                 </a:solidFill>
               </a:rPr>
-              <a:t>https://github.com/Ad1thh/KLA-Semicon-AI-Restoration (Complete, public, and fully documented)</a:t>
+              <a:t>https://github.com/Ad1thh/KLA-Semicon-AI-Restoration (Public &amp; Complete)</a:t>
             </a:r>
           </a:p>
           <a:p>
@@ -4186,7 +4186,7 @@
                   <a:srgbClr val="0F172A"/>
                 </a:solidFill>
               </a:rPr>
-              <a:t>•  Inference CLI Contract: </a:t>
+              <a:t>*  Inference CLI Contract: </a:t>
             </a:r>
             <a:r>
               <a:rPr sz="1250">
@@ -4209,7 +4209,7 @@
                   <a:srgbClr val="0F172A"/>
                 </a:solidFill>
               </a:rPr>
-              <a:t>•  Deliverables Checklist: </a:t>
+              <a:t>*  Reproducible Weights: </a:t>
             </a:r>
             <a:r>
               <a:rPr sz="1250">
@@ -4217,7 +4217,7 @@
                   <a:srgbClr val="1E293B"/>
                 </a:solidFill>
               </a:rPr>
-              <a:t>Presentation (.pptx &amp; .pdf), requirements.txt, best checkpoint weights, 6 visual triplets, and clean code.</a:t>
+              <a:t>Tracked directly in Git repository (weights/nafnet_sr_best.pt, 56.15 MB, no download script needed).</a:t>
             </a:r>
           </a:p>
           <a:p>
@@ -4232,7 +4232,7 @@
                   <a:srgbClr val="0F172A"/>
                 </a:solidFill>
               </a:rPr>
-              <a:t>•  Open-Source Attribution: </a:t>
+              <a:t>*  Deliverables Checklist: </a:t>
             </a:r>
             <a:r>
               <a:rPr sz="1250">
@@ -4240,30 +4240,7 @@
                   <a:srgbClr val="1E293B"/>
                 </a:solidFill>
               </a:rPr>
-              <a:t>PyTorch (BSD-3), torchvision (BSD-3), LPIPS (BSD-2), pytorch-msssim (MIT), NumPy (BSD).</a:t>
-            </a:r>
-          </a:p>
-          <a:p>
-            <a:pPr>
-              <a:spcAft>
-                <a:spcPts val="1200"/>
-              </a:spcAft>
-            </a:pPr>
-            <a:r>
-              <a:rPr b="1" sz="1300">
-                <a:solidFill>
-                  <a:srgbClr val="0F172A"/>
-                </a:solidFill>
-              </a:rPr>
-              <a:t>•  Final Verdict: </a:t>
-            </a:r>
-            <a:r>
-              <a:rPr sz="1250">
-                <a:solidFill>
-                  <a:srgbClr val="1E293B"/>
-                </a:solidFill>
-              </a:rPr>
-              <a:t>Production-grade, highly accurate, and real-time AI solution ready for semiconductor inspection evaluation.</a:t>
+              <a:t>Presentation (.pptx &amp; .pdf), requirements.txt, best checkpoint weights, 6 visual triplets, and clean code.</a:t>
             </a:r>
           </a:p>
         </p:txBody>
@@ -4480,7 +4457,7 @@
                   <a:srgbClr val="0F172A"/>
                 </a:solidFill>
               </a:rPr>
-              <a:t>•  Inspection Physics: </a:t>
+              <a:t>*  Inspection Physics: </a:t>
             </a:r>
             <a:r>
               <a:rPr sz="1250">
@@ -4488,7 +4465,7 @@
                   <a:srgbClr val="1E293B"/>
                 </a:solidFill>
               </a:rPr>
-              <a:t>High-speed optical and e-beam imaging of nanometer wafer circuits suffer from photon starvation, sensor thermal noise, and optical diffraction limits.</a:t>
+              <a:t>High-speed optical and e-beam imaging suffer from photon starvation, sensor thermal noise, and diffraction limits.</a:t>
             </a:r>
           </a:p>
           <a:p>
@@ -4503,7 +4480,7 @@
                   <a:srgbClr val="0F172A"/>
                 </a:solidFill>
               </a:rPr>
-              <a:t>•  Restoration Objective: </a:t>
+              <a:t>*  Restoration Objective: </a:t>
             </a:r>
             <a:r>
               <a:rPr sz="1250">
@@ -4526,7 +4503,7 @@
                   <a:srgbClr val="0F172A"/>
                 </a:solidFill>
               </a:rPr>
-              <a:t>•  Invariant 1: Unclipped Inputs: </a:t>
+              <a:t>*  Invariant 1: Unclipped Inputs: </a:t>
             </a:r>
             <a:r>
               <a:rPr sz="1250">
@@ -4549,7 +4526,7 @@
                   <a:srgbClr val="0F172A"/>
                 </a:solidFill>
               </a:rPr>
-              <a:t>•  Invariant 2: Bounded Outputs: </a:t>
+              <a:t>*  Invariant 2: Bounded Outputs: </a:t>
             </a:r>
             <a:r>
               <a:rPr sz="1250">
@@ -4572,7 +4549,7 @@
                   <a:srgbClr val="0F172A"/>
                 </a:solidFill>
               </a:rPr>
-              <a:t>•  Invariant 3: Evaluator Contract: </a:t>
+              <a:t>*  Invariant 3: Evaluator Contract: </a:t>
             </a:r>
             <a:r>
               <a:rPr sz="1250">
@@ -4696,7 +4673,7 @@
             <a:avLst/>
           </a:prstGeom>
           <a:solidFill>
-            <a:srgbClr val="0052CC"/>
+            <a:srgbClr val="0065FF"/>
           </a:solidFill>
           <a:ln>
             <a:noFill/>
@@ -4797,7 +4774,7 @@
                   <a:srgbClr val="0F172A"/>
                 </a:solidFill>
               </a:rPr>
-              <a:t>•  Multiplicative Speckle Noise: </a:t>
+              <a:t>*  Multiplicative Speckle Noise: </a:t>
             </a:r>
             <a:r>
               <a:rPr sz="1250">
@@ -4820,7 +4797,7 @@
                   <a:srgbClr val="0F172A"/>
                 </a:solidFill>
               </a:rPr>
-              <a:t>•  Additive Gaussian Noise: </a:t>
+              <a:t>*  Additive Gaussian Noise: </a:t>
             </a:r>
             <a:r>
               <a:rPr sz="1250">
@@ -4843,7 +4820,7 @@
                   <a:srgbClr val="0F172A"/>
                 </a:solidFill>
               </a:rPr>
-              <a:t>•  Spatial Decimation: </a:t>
+              <a:t>*  Spatial Decimation: </a:t>
             </a:r>
             <a:r>
               <a:rPr sz="1250">
@@ -4866,7 +4843,7 @@
                   <a:srgbClr val="0F172A"/>
                 </a:solidFill>
               </a:rPr>
-              <a:t>•  Permutation Invariance: </a:t>
+              <a:t>*  Permutation Invariance: </a:t>
             </a:r>
             <a:r>
               <a:rPr sz="1250">
@@ -4889,7 +4866,7 @@
                   <a:srgbClr val="0F172A"/>
                 </a:solidFill>
               </a:rPr>
-              <a:t>•  Dataset Audit &amp; Split: </a:t>
+              <a:t>*  Dataset Audit &amp; Split: </a:t>
             </a:r>
             <a:r>
               <a:rPr sz="1250">
@@ -5013,7 +4990,7 @@
             <a:avLst/>
           </a:prstGeom>
           <a:solidFill>
-            <a:srgbClr val="0052CC"/>
+            <a:srgbClr val="00875A"/>
           </a:solidFill>
           <a:ln>
             <a:noFill/>
@@ -5114,7 +5091,7 @@
                   <a:srgbClr val="0F172A"/>
                 </a:solidFill>
               </a:rPr>
-              <a:t>•  Input Ingestion: </a:t>
+              <a:t>*  Input Ingestion: </a:t>
             </a:r>
             <a:r>
               <a:rPr sz="1250">
@@ -5137,7 +5114,7 @@
                   <a:srgbClr val="0F172A"/>
                 </a:solidFill>
               </a:rPr>
-              <a:t>•  Global Residual Base: </a:t>
+              <a:t>*  Global Residual Base: </a:t>
             </a:r>
             <a:r>
               <a:rPr sz="1250">
@@ -5160,7 +5137,7 @@
                   <a:srgbClr val="0F172A"/>
                 </a:solidFill>
               </a:rPr>
-              <a:t>•  Deep Restoration Core: </a:t>
+              <a:t>*  Deep Restoration Core: </a:t>
             </a:r>
             <a:r>
               <a:rPr sz="1250">
@@ -5168,7 +5145,7 @@
                   <a:srgbClr val="1E293B"/>
                 </a:solidFill>
               </a:rPr>
-              <a:t>4-stage NAFNet-SR encoder-decoder with skip connections extracts multi-scale spatial and frequency features.</a:t>
+              <a:t>4-stage NAFNet-SR encoder-decoder with skip connections extracts multi-scale spatial and frequency features (29.33M params).</a:t>
             </a:r>
           </a:p>
           <a:p>
@@ -5183,7 +5160,7 @@
                   <a:srgbClr val="0F172A"/>
                 </a:solidFill>
               </a:rPr>
-              <a:t>•  Sub-Pixel Upsampling Head: </a:t>
+              <a:t>*  Sub-Pixel Upsampling Head: </a:t>
             </a:r>
             <a:r>
               <a:rPr sz="1250">
@@ -5206,7 +5183,7 @@
                   <a:srgbClr val="0F172A"/>
                 </a:solidFill>
               </a:rPr>
-              <a:t>•  Post-Processing &amp; Output: </a:t>
+              <a:t>*  Post-Processing &amp; Output: </a:t>
             </a:r>
             <a:r>
               <a:rPr sz="1250">
@@ -5330,7 +5307,7 @@
             <a:avLst/>
           </a:prstGeom>
           <a:solidFill>
-            <a:srgbClr val="0052CC"/>
+            <a:srgbClr val="6554C0"/>
           </a:solidFill>
           <a:ln>
             <a:noFill/>
@@ -5431,7 +5408,7 @@
                   <a:srgbClr val="0F172A"/>
                 </a:solidFill>
               </a:rPr>
-              <a:t>•  Zero Heuristic Filtering: </a:t>
+              <a:t>*  Zero Heuristic Filtering: </a:t>
             </a:r>
             <a:r>
               <a:rPr sz="1250">
@@ -5454,7 +5431,7 @@
                   <a:srgbClr val="0F172A"/>
                 </a:solidFill>
               </a:rPr>
-              <a:t>•  Geometric Symmetries: </a:t>
+              <a:t>*  Geometric Symmetries: </a:t>
             </a:r>
             <a:r>
               <a:rPr sz="1250">
@@ -5477,7 +5454,7 @@
                   <a:srgbClr val="0F172A"/>
                 </a:solidFill>
               </a:rPr>
-              <a:t>•  Multi-Order Synthetic Degradations: </a:t>
+              <a:t>*  Multi-Order Synthetic Degradations: </a:t>
             </a:r>
             <a:r>
               <a:rPr sz="1250">
@@ -5500,7 +5477,7 @@
                   <a:srgbClr val="0F172A"/>
                 </a:solidFill>
               </a:rPr>
-              <a:t>•  High-Speed RAM Caching: </a:t>
+              <a:t>*  High-Speed RAM Caching: </a:t>
             </a:r>
             <a:r>
               <a:rPr sz="1250">
@@ -5624,7 +5601,7 @@
             <a:avLst/>
           </a:prstGeom>
           <a:solidFill>
-            <a:srgbClr val="0052CC"/>
+            <a:srgbClr val="36B37E"/>
           </a:solidFill>
           <a:ln>
             <a:noFill/>
@@ -5725,7 +5702,7 @@
                   <a:srgbClr val="0F172A"/>
                 </a:solidFill>
               </a:rPr>
-              <a:t>•  SimpleGate (SG): </a:t>
+              <a:t>*  SimpleGate (SG): </a:t>
             </a:r>
             <a:r>
               <a:rPr sz="1250">
@@ -5748,7 +5725,7 @@
                   <a:srgbClr val="0F172A"/>
                 </a:solidFill>
               </a:rPr>
-              <a:t>•  Simplified Channel Attention (SCA): </a:t>
+              <a:t>*  Simplified Channel Attention (SCA): </a:t>
             </a:r>
             <a:r>
               <a:rPr sz="1250">
@@ -5771,7 +5748,7 @@
                   <a:srgbClr val="0F172A"/>
                 </a:solidFill>
               </a:rPr>
-              <a:t>•  Depthwise Convolutions: </a:t>
+              <a:t>*  Depthwise Convolutions: </a:t>
             </a:r>
             <a:r>
               <a:rPr sz="1250">
@@ -5794,7 +5771,7 @@
                   <a:srgbClr val="0F172A"/>
                 </a:solidFill>
               </a:rPr>
-              <a:t>•  Channel LayerNorm2d: </a:t>
+              <a:t>*  Channel LayerNorm2d: </a:t>
             </a:r>
             <a:r>
               <a:rPr sz="1250">
@@ -5817,7 +5794,7 @@
                   <a:srgbClr val="0F172A"/>
                 </a:solidFill>
               </a:rPr>
-              <a:t>•  Parameter Capacity: </a:t>
+              <a:t>*  Parameter Capacity: </a:t>
             </a:r>
             <a:r>
               <a:rPr sz="1250">
@@ -5825,7 +5802,7 @@
                   <a:srgbClr val="1E293B"/>
                 </a:solidFill>
               </a:rPr>
-              <a:t>29.33 Million parameters (15x larger than a basic U-Net), striking an ideal balance between representation capacity and real-time inference.</a:t>
+              <a:t>29.33 Million parameters (15x larger than a basic U-Net), providing high restoration expressiveness.</a:t>
             </a:r>
           </a:p>
         </p:txBody>
@@ -5941,7 +5918,7 @@
             <a:avLst/>
           </a:prstGeom>
           <a:solidFill>
-            <a:srgbClr val="0052CC"/>
+            <a:srgbClr val="FF5630"/>
           </a:solidFill>
           <a:ln>
             <a:noFill/>
@@ -6042,7 +6019,7 @@
                   <a:srgbClr val="0F172A"/>
                 </a:solidFill>
               </a:rPr>
-              <a:t>•  Total Objective: </a:t>
+              <a:t>*  Total Objective: </a:t>
             </a:r>
             <a:r>
               <a:rPr sz="1250">
@@ -6065,7 +6042,7 @@
                   <a:srgbClr val="0F172A"/>
                 </a:solidFill>
               </a:rPr>
-              <a:t>•  1. Charbonnier Spatial Loss (1.0): </a:t>
+              <a:t>*  1. Charbonnier Spatial Loss (1.0): </a:t>
             </a:r>
             <a:r>
               <a:rPr sz="1250">
@@ -6088,7 +6065,7 @@
                   <a:srgbClr val="0F172A"/>
                 </a:solidFill>
               </a:rPr>
-              <a:t>•  2. Structural Similarity (0.5): </a:t>
+              <a:t>*  2. Structural Similarity (0.5): </a:t>
             </a:r>
             <a:r>
               <a:rPr sz="1250">
@@ -6111,7 +6088,7 @@
                   <a:srgbClr val="0F172A"/>
                 </a:solidFill>
               </a:rPr>
-              <a:t>•  3. 2D Fast Fourier Transform Loss (0.1): </a:t>
+              <a:t>*  3. 2D Fast Fourier Transform Loss (0.1): </a:t>
             </a:r>
             <a:r>
               <a:rPr sz="1250">
@@ -6134,7 +6111,7 @@
                   <a:srgbClr val="0F172A"/>
                 </a:solidFill>
               </a:rPr>
-              <a:t>•  4. Perceptual LPIPS Loss (0.02): </a:t>
+              <a:t>*  4. Perceptual LPIPS Loss (0.02): </a:t>
             </a:r>
             <a:r>
               <a:rPr sz="1250">
@@ -6258,7 +6235,7 @@
             <a:avLst/>
           </a:prstGeom>
           <a:solidFill>
-            <a:srgbClr val="0052CC"/>
+            <a:srgbClr val="FFAB00"/>
           </a:solidFill>
           <a:ln>
             <a:noFill/>
@@ -6359,7 +6336,7 @@
                   <a:srgbClr val="0F172A"/>
                 </a:solidFill>
               </a:rPr>
-              <a:t>•  Sanity Protocol: </a:t>
+              <a:t>*  Sanity Protocol: </a:t>
             </a:r>
             <a:r>
               <a:rPr sz="1250">
@@ -6382,7 +6359,7 @@
                   <a:srgbClr val="0F172A"/>
                 </a:solidFill>
               </a:rPr>
-              <a:t>•  Verification Criterion: </a:t>
+              <a:t>*  Verification Criterion: </a:t>
             </a:r>
             <a:r>
               <a:rPr sz="1250">
@@ -6405,7 +6382,7 @@
                   <a:srgbClr val="0F172A"/>
                 </a:solidFill>
               </a:rPr>
-              <a:t>•  Empirical Result: </a:t>
+              <a:t>*  Empirical Result: </a:t>
             </a:r>
             <a:r>
               <a:rPr sz="1250">
@@ -6428,7 +6405,7 @@
                   <a:srgbClr val="0F172A"/>
                 </a:solidFill>
               </a:rPr>
-              <a:t>•  Conclusion: </a:t>
+              <a:t>*  Conclusion: </a:t>
             </a:r>
             <a:r>
               <a:rPr sz="1250">
@@ -6552,7 +6529,7 @@
             <a:avLst/>
           </a:prstGeom>
           <a:solidFill>
-            <a:srgbClr val="0052CC"/>
+            <a:srgbClr val="00B8D9"/>
           </a:solidFill>
           <a:ln>
             <a:noFill/>
@@ -6653,7 +6630,7 @@
                   <a:srgbClr val="0F172A"/>
                 </a:solidFill>
               </a:rPr>
-              <a:t>•  Bicubic Baseline: </a:t>
+              <a:t>*  Bicubic Baseline: </a:t>
             </a:r>
             <a:r>
               <a:rPr sz="1250">
@@ -6661,7 +6638,7 @@
                   <a:srgbClr val="1E293B"/>
                 </a:solidFill>
               </a:rPr>
-              <a:t>PSNR: 23.0065 dB | SSIM: 0.5286 | LPIPS: 0.4428</a:t>
+              <a:t>PSNR: 23.01 ± 3.65 dB | SSIM: 0.5286 ± 0.1950 | LPIPS: 0.4428 ± 0.1618</a:t>
             </a:r>
           </a:p>
           <a:p>
@@ -6676,7 +6653,7 @@
                   <a:srgbClr val="0F172A"/>
                 </a:solidFill>
               </a:rPr>
-              <a:t>•  Classical U-Net (Friend's Baseline): </a:t>
+              <a:t>*  Classical U-Net (Baseline Repo): </a:t>
             </a:r>
             <a:r>
               <a:rPr sz="1250">
@@ -6684,7 +6661,7 @@
                   <a:srgbClr val="1E293B"/>
                 </a:solidFill>
               </a:rPr>
-              <a:t>PSNR: 27.1700 dB | SSIM: 0.7121 | LPIPS: 0.2600 (30 epochs)</a:t>
+              <a:t>PSNR: 27.17 ± 4.30 dB | SSIM: 0.7121 ± 0.1472 | LPIPS: 0.2600 ± 0.1100 (1.93M params)</a:t>
             </a:r>
           </a:p>
           <a:p>
@@ -6699,7 +6676,7 @@
                   <a:srgbClr val="0F172A"/>
                 </a:solidFill>
               </a:rPr>
-              <a:t>•  NAFNet-SR (Our Solution): </a:t>
+              <a:t>*  NAFNet-SR (Our Solution): </a:t>
             </a:r>
             <a:r>
               <a:rPr sz="1250">
@@ -6707,7 +6684,7 @@
                   <a:srgbClr val="1E293B"/>
                 </a:solidFill>
               </a:rPr>
-              <a:t>PSNR: 28.1599 dB | SSIM: 0.7661 | LPIPS: 0.2298 (10 epochs)</a:t>
+              <a:t>PSNR: 28.16 ± 5.02 dB | SSIM: 0.7661 ± 0.1571 | LPIPS: 0.2277 ± 0.1222 (29.33M params)</a:t>
             </a:r>
           </a:p>
           <a:p>
@@ -6722,7 +6699,7 @@
                   <a:srgbClr val="0F172A"/>
                 </a:solidFill>
               </a:rPr>
-              <a:t>•  Net Improvement vs. Bicubic: </a:t>
+              <a:t>*  Net Improvement vs. Bicubic: </a:t>
             </a:r>
             <a:r>
               <a:rPr sz="1250">
@@ -6730,7 +6707,7 @@
                   <a:srgbClr val="1E293B"/>
                 </a:solidFill>
               </a:rPr>
-              <a:t>+5.15 dB PSNR Gain | +0.2375 SSIM Structural Gain | -48.1% Perceptual Distortion Drop</a:t>
+              <a:t>+5.15 dB PSNR Gain | +0.2375 SSIM Structural Gain | -48.6% Perceptual Distortion Drop</a:t>
             </a:r>
           </a:p>
           <a:p>
@@ -6745,7 +6722,7 @@
                   <a:srgbClr val="0F172A"/>
                 </a:solidFill>
               </a:rPr>
-              <a:t>•  Advantage vs. Classical U-Net: </a:t>
+              <a:t>*  Advantage vs. Classical U-Net: </a:t>
             </a:r>
             <a:r>
               <a:rPr sz="1250">
@@ -6753,7 +6730,7 @@
                   <a:srgbClr val="1E293B"/>
                 </a:solidFill>
               </a:rPr>
-              <a:t>+0.99 dB higher PSNR, +0.054 higher SSIM, and 12% lower perceptual LPIPS error with superior line definition.</a:t>
+              <a:t>+0.99 dB higher PSNR, +0.054 higher SSIM, and lower perceptual error with superior line definition.</a:t>
             </a:r>
           </a:p>
         </p:txBody>

</xml_diff>